<commit_message>
Add HTML slide decks and update python functions slides
- Update module-01 python functions PPTX slides
- Add HTML versions of python functions and intro to classes slides
- Add LineSensor_Blueprint PDF reference
- Update Claude settings and skills

Co-Authored-By: Claude Opus 4.6 <noreply@anthropic.com>
</commit_message>
<xml_diff>
--- a/module-01-driving/slides/10-python-functions.pptx
+++ b/module-01-driving/slides/10-python-functions.pptx
@@ -3742,7 +3742,7 @@
               <a:spcAft>
                 <a:spcPts val="100"/>
               </a:spcAft>
-              <a:defRPr sz="1300">
+              <a:defRPr sz="1800">
                 <a:solidFill>
                   <a:srgbClr val="333333"/>
                 </a:solidFill>
@@ -3758,7 +3758,7 @@
               <a:spcAft>
                 <a:spcPts val="100"/>
               </a:spcAft>
-              <a:defRPr sz="1300">
+              <a:defRPr sz="1800">
                 <a:solidFill>
                   <a:srgbClr val="333333"/>
                 </a:solidFill>
@@ -3774,20 +3774,20 @@
               <a:spcAft>
                 <a:spcPts val="100"/>
               </a:spcAft>
-              <a:defRPr sz="1300">
-                <a:solidFill>
-                  <a:srgbClr val="333333"/>
-                </a:solidFill>
-                <a:latin typeface="Courier New"/>
-              </a:defRPr>
-            </a:pPr>
-          </a:p>
-          <a:p>
-            <a:pPr>
-              <a:spcAft>
-                <a:spcPts val="100"/>
-              </a:spcAft>
-              <a:defRPr sz="1300">
+              <a:defRPr sz="1800">
+                <a:solidFill>
+                  <a:srgbClr val="333333"/>
+                </a:solidFill>
+                <a:latin typeface="Courier New"/>
+              </a:defRPr>
+            </a:pPr>
+          </a:p>
+          <a:p>
+            <a:pPr>
+              <a:spcAft>
+                <a:spcPts val="100"/>
+              </a:spcAft>
+              <a:defRPr sz="1800">
                 <a:solidFill>
                   <a:srgbClr val="333333"/>
                 </a:solidFill>
@@ -3803,7 +3803,7 @@
               <a:spcAft>
                 <a:spcPts val="100"/>
               </a:spcAft>
-              <a:defRPr sz="1300">
+              <a:defRPr sz="1800">
                 <a:solidFill>
                   <a:srgbClr val="333333"/>
                 </a:solidFill>
@@ -3887,7 +3887,7 @@
               <a:spcAft>
                 <a:spcPts val="100"/>
               </a:spcAft>
-              <a:defRPr sz="1300">
+              <a:defRPr sz="1800">
                 <a:solidFill>
                   <a:srgbClr val="333333"/>
                 </a:solidFill>
@@ -3903,7 +3903,7 @@
               <a:spcAft>
                 <a:spcPts val="100"/>
               </a:spcAft>
-              <a:defRPr sz="1300">
+              <a:defRPr sz="1800">
                 <a:solidFill>
                   <a:srgbClr val="333333"/>
                 </a:solidFill>
@@ -3919,7 +3919,7 @@
               <a:spcAft>
                 <a:spcPts val="100"/>
               </a:spcAft>
-              <a:defRPr sz="1300">
+              <a:defRPr sz="1800">
                 <a:solidFill>
                   <a:srgbClr val="333333"/>
                 </a:solidFill>
@@ -3935,20 +3935,20 @@
               <a:spcAft>
                 <a:spcPts val="100"/>
               </a:spcAft>
-              <a:defRPr sz="1300">
-                <a:solidFill>
-                  <a:srgbClr val="333333"/>
-                </a:solidFill>
-                <a:latin typeface="Courier New"/>
-              </a:defRPr>
-            </a:pPr>
-          </a:p>
-          <a:p>
-            <a:pPr>
-              <a:spcAft>
-                <a:spcPts val="100"/>
-              </a:spcAft>
-              <a:defRPr sz="1300">
+              <a:defRPr sz="1800">
+                <a:solidFill>
+                  <a:srgbClr val="333333"/>
+                </a:solidFill>
+                <a:latin typeface="Courier New"/>
+              </a:defRPr>
+            </a:pPr>
+          </a:p>
+          <a:p>
+            <a:pPr>
+              <a:spcAft>
+                <a:spcPts val="100"/>
+              </a:spcAft>
+              <a:defRPr sz="1800">
                 <a:solidFill>
                   <a:srgbClr val="333333"/>
                 </a:solidFill>
@@ -3964,7 +3964,7 @@
               <a:spcAft>
                 <a:spcPts val="100"/>
               </a:spcAft>
-              <a:defRPr sz="1300">
+              <a:defRPr sz="1800">
                 <a:solidFill>
                   <a:srgbClr val="333333"/>
                 </a:solidFill>
@@ -3986,7 +3986,7 @@
         <p:spPr>
           <a:xfrm>
             <a:off x="548640" y="4251960"/>
-            <a:ext cx="10972800" cy="1417320"/>
+            <a:ext cx="10972800" cy="1234440"/>
           </a:xfrm>
           <a:prstGeom prst="roundRect">
             <a:avLst/>
@@ -4031,7 +4031,7 @@
         <p:spPr>
           <a:xfrm>
             <a:off x="731520" y="4343400"/>
-            <a:ext cx="10607040" cy="1234440"/>
+            <a:ext cx="10607040" cy="1051560"/>
           </a:xfrm>
           <a:prstGeom prst="rect">
             <a:avLst/>
@@ -4048,7 +4048,7 @@
               <a:spcAft>
                 <a:spcPts val="100"/>
               </a:spcAft>
-              <a:defRPr sz="1300">
+              <a:defRPr sz="1800">
                 <a:solidFill>
                   <a:srgbClr val="333333"/>
                 </a:solidFill>
@@ -4064,7 +4064,7 @@
               <a:spcAft>
                 <a:spcPts val="100"/>
               </a:spcAft>
-              <a:defRPr sz="1300">
+              <a:defRPr sz="1800">
                 <a:solidFill>
                   <a:srgbClr val="333333"/>
                 </a:solidFill>
@@ -4080,7 +4080,7 @@
               <a:spcAft>
                 <a:spcPts val="100"/>
               </a:spcAft>
-              <a:defRPr sz="1300">
+              <a:defRPr sz="1800">
                 <a:solidFill>
                   <a:srgbClr val="333333"/>
                 </a:solidFill>
@@ -4096,20 +4096,20 @@
               <a:spcAft>
                 <a:spcPts val="100"/>
               </a:spcAft>
-              <a:defRPr sz="1300">
-                <a:solidFill>
-                  <a:srgbClr val="333333"/>
-                </a:solidFill>
-                <a:latin typeface="Courier New"/>
-              </a:defRPr>
-            </a:pPr>
-          </a:p>
-          <a:p>
-            <a:pPr>
-              <a:spcAft>
-                <a:spcPts val="100"/>
-              </a:spcAft>
-              <a:defRPr sz="1300">
+              <a:defRPr sz="1800">
+                <a:solidFill>
+                  <a:srgbClr val="333333"/>
+                </a:solidFill>
+                <a:latin typeface="Courier New"/>
+              </a:defRPr>
+            </a:pPr>
+          </a:p>
+          <a:p>
+            <a:pPr>
+              <a:spcAft>
+                <a:spcPts val="100"/>
+              </a:spcAft>
+              <a:defRPr sz="1800">
                 <a:solidFill>
                   <a:srgbClr val="333333"/>
                 </a:solidFill>
@@ -4324,7 +4324,7 @@
         <p:spPr>
           <a:xfrm>
             <a:off x="548640" y="2194560"/>
-            <a:ext cx="5303520" cy="3200400"/>
+            <a:ext cx="5303520" cy="3246120"/>
           </a:xfrm>
           <a:prstGeom prst="roundRect">
             <a:avLst/>
@@ -4369,7 +4369,7 @@
         <p:spPr>
           <a:xfrm>
             <a:off x="731520" y="2286000"/>
-            <a:ext cx="4937760" cy="3017520"/>
+            <a:ext cx="4937760" cy="3063240"/>
           </a:xfrm>
           <a:prstGeom prst="rect">
             <a:avLst/>
@@ -4386,7 +4386,7 @@
               <a:spcAft>
                 <a:spcPts val="100"/>
               </a:spcAft>
-              <a:defRPr sz="1300">
+              <a:defRPr sz="1800">
                 <a:solidFill>
                   <a:srgbClr val="333333"/>
                 </a:solidFill>
@@ -4402,7 +4402,7 @@
               <a:spcAft>
                 <a:spcPts val="100"/>
               </a:spcAft>
-              <a:defRPr sz="1300">
+              <a:defRPr sz="1800">
                 <a:solidFill>
                   <a:srgbClr val="333333"/>
                 </a:solidFill>
@@ -4418,7 +4418,7 @@
               <a:spcAft>
                 <a:spcPts val="100"/>
               </a:spcAft>
-              <a:defRPr sz="1300">
+              <a:defRPr sz="1800">
                 <a:solidFill>
                   <a:srgbClr val="333333"/>
                 </a:solidFill>
@@ -4434,7 +4434,7 @@
               <a:spcAft>
                 <a:spcPts val="100"/>
               </a:spcAft>
-              <a:defRPr sz="1300">
+              <a:defRPr sz="1800">
                 <a:solidFill>
                   <a:srgbClr val="333333"/>
                 </a:solidFill>
@@ -4450,20 +4450,20 @@
               <a:spcAft>
                 <a:spcPts val="100"/>
               </a:spcAft>
-              <a:defRPr sz="1300">
-                <a:solidFill>
-                  <a:srgbClr val="333333"/>
-                </a:solidFill>
-                <a:latin typeface="Courier New"/>
-              </a:defRPr>
-            </a:pPr>
-          </a:p>
-          <a:p>
-            <a:pPr>
-              <a:spcAft>
-                <a:spcPts val="100"/>
-              </a:spcAft>
-              <a:defRPr sz="1300">
+              <a:defRPr sz="1800">
+                <a:solidFill>
+                  <a:srgbClr val="333333"/>
+                </a:solidFill>
+                <a:latin typeface="Courier New"/>
+              </a:defRPr>
+            </a:pPr>
+          </a:p>
+          <a:p>
+            <a:pPr>
+              <a:spcAft>
+                <a:spcPts val="100"/>
+              </a:spcAft>
+              <a:defRPr sz="1800">
                 <a:solidFill>
                   <a:srgbClr val="333333"/>
                 </a:solidFill>
@@ -4479,7 +4479,7 @@
               <a:spcAft>
                 <a:spcPts val="100"/>
               </a:spcAft>
-              <a:defRPr sz="1300">
+              <a:defRPr sz="1800">
                 <a:solidFill>
                   <a:srgbClr val="333333"/>
                 </a:solidFill>
@@ -4495,7 +4495,7 @@
               <a:spcAft>
                 <a:spcPts val="100"/>
               </a:spcAft>
-              <a:defRPr sz="1300">
+              <a:defRPr sz="1800">
                 <a:solidFill>
                   <a:srgbClr val="333333"/>
                 </a:solidFill>
@@ -4511,7 +4511,7 @@
               <a:spcAft>
                 <a:spcPts val="100"/>
               </a:spcAft>
-              <a:defRPr sz="1300">
+              <a:defRPr sz="1800">
                 <a:solidFill>
                   <a:srgbClr val="333333"/>
                 </a:solidFill>
@@ -4527,7 +4527,7 @@
               <a:spcAft>
                 <a:spcPts val="100"/>
               </a:spcAft>
-              <a:defRPr sz="1300">
+              <a:defRPr sz="1800">
                 <a:solidFill>
                   <a:srgbClr val="333333"/>
                 </a:solidFill>
@@ -4549,7 +4549,7 @@
         <p:spPr>
           <a:xfrm>
             <a:off x="6217920" y="2194560"/>
-            <a:ext cx="5303520" cy="3200400"/>
+            <a:ext cx="5303520" cy="3246120"/>
           </a:xfrm>
           <a:prstGeom prst="roundRect">
             <a:avLst/>
@@ -4594,7 +4594,7 @@
         <p:spPr>
           <a:xfrm>
             <a:off x="6400800" y="2286000"/>
-            <a:ext cx="4937760" cy="3017520"/>
+            <a:ext cx="4937760" cy="3063240"/>
           </a:xfrm>
           <a:prstGeom prst="rect">
             <a:avLst/>
@@ -4611,7 +4611,7 @@
               <a:spcAft>
                 <a:spcPts val="100"/>
               </a:spcAft>
-              <a:defRPr sz="1300">
+              <a:defRPr sz="1800">
                 <a:solidFill>
                   <a:srgbClr val="333333"/>
                 </a:solidFill>
@@ -4627,7 +4627,7 @@
               <a:spcAft>
                 <a:spcPts val="100"/>
               </a:spcAft>
-              <a:defRPr sz="1300">
+              <a:defRPr sz="1800">
                 <a:solidFill>
                   <a:srgbClr val="333333"/>
                 </a:solidFill>
@@ -4643,7 +4643,7 @@
               <a:spcAft>
                 <a:spcPts val="100"/>
               </a:spcAft>
-              <a:defRPr sz="1300">
+              <a:defRPr sz="1800">
                 <a:solidFill>
                   <a:srgbClr val="333333"/>
                 </a:solidFill>
@@ -4659,7 +4659,7 @@
               <a:spcAft>
                 <a:spcPts val="100"/>
               </a:spcAft>
-              <a:defRPr sz="1300">
+              <a:defRPr sz="1800">
                 <a:solidFill>
                   <a:srgbClr val="333333"/>
                 </a:solidFill>
@@ -4675,20 +4675,20 @@
               <a:spcAft>
                 <a:spcPts val="100"/>
               </a:spcAft>
-              <a:defRPr sz="1300">
-                <a:solidFill>
-                  <a:srgbClr val="333333"/>
-                </a:solidFill>
-                <a:latin typeface="Courier New"/>
-              </a:defRPr>
-            </a:pPr>
-          </a:p>
-          <a:p>
-            <a:pPr>
-              <a:spcAft>
-                <a:spcPts val="100"/>
-              </a:spcAft>
-              <a:defRPr sz="1300">
+              <a:defRPr sz="1800">
+                <a:solidFill>
+                  <a:srgbClr val="333333"/>
+                </a:solidFill>
+                <a:latin typeface="Courier New"/>
+              </a:defRPr>
+            </a:pPr>
+          </a:p>
+          <a:p>
+            <a:pPr>
+              <a:spcAft>
+                <a:spcPts val="100"/>
+              </a:spcAft>
+              <a:defRPr sz="1800">
                 <a:solidFill>
                   <a:srgbClr val="333333"/>
                 </a:solidFill>
@@ -4704,7 +4704,7 @@
               <a:spcAft>
                 <a:spcPts val="100"/>
               </a:spcAft>
-              <a:defRPr sz="1300">
+              <a:defRPr sz="1800">
                 <a:solidFill>
                   <a:srgbClr val="333333"/>
                 </a:solidFill>
@@ -4720,7 +4720,7 @@
               <a:spcAft>
                 <a:spcPts val="100"/>
               </a:spcAft>
-              <a:defRPr sz="1300">
+              <a:defRPr sz="1800">
                 <a:solidFill>
                   <a:srgbClr val="333333"/>
                 </a:solidFill>
@@ -4736,7 +4736,7 @@
               <a:spcAft>
                 <a:spcPts val="100"/>
               </a:spcAft>
-              <a:defRPr sz="1300">
+              <a:defRPr sz="1800">
                 <a:solidFill>
                   <a:srgbClr val="333333"/>
                 </a:solidFill>
@@ -4752,7 +4752,7 @@
               <a:spcAft>
                 <a:spcPts val="100"/>
               </a:spcAft>
-              <a:defRPr sz="1300">
+              <a:defRPr sz="1800">
                 <a:solidFill>
                   <a:srgbClr val="333333"/>
                 </a:solidFill>
@@ -4768,7 +4768,7 @@
               <a:spcAft>
                 <a:spcPts val="100"/>
               </a:spcAft>
-              <a:defRPr sz="1300">
+              <a:defRPr sz="1800">
                 <a:solidFill>
                   <a:srgbClr val="333333"/>
                 </a:solidFill>
@@ -4784,20 +4784,20 @@
               <a:spcAft>
                 <a:spcPts val="100"/>
               </a:spcAft>
-              <a:defRPr sz="1300">
-                <a:solidFill>
-                  <a:srgbClr val="333333"/>
-                </a:solidFill>
-                <a:latin typeface="Courier New"/>
-              </a:defRPr>
-            </a:pPr>
-          </a:p>
-          <a:p>
-            <a:pPr>
-              <a:spcAft>
-                <a:spcPts val="100"/>
-              </a:spcAft>
-              <a:defRPr sz="1300">
+              <a:defRPr sz="1800">
+                <a:solidFill>
+                  <a:srgbClr val="333333"/>
+                </a:solidFill>
+                <a:latin typeface="Courier New"/>
+              </a:defRPr>
+            </a:pPr>
+          </a:p>
+          <a:p>
+            <a:pPr>
+              <a:spcAft>
+                <a:spcPts val="100"/>
+              </a:spcAft>
+              <a:defRPr sz="1800">
                 <a:solidFill>
                   <a:srgbClr val="333333"/>
                 </a:solidFill>
@@ -5016,7 +5016,7 @@
         <p:spPr>
           <a:xfrm>
             <a:off x="548640" y="2743200"/>
-            <a:ext cx="5669280" cy="3657600"/>
+            <a:ext cx="5669280" cy="3200400"/>
           </a:xfrm>
           <a:prstGeom prst="roundRect">
             <a:avLst/>
@@ -5061,7 +5061,7 @@
         <p:spPr>
           <a:xfrm>
             <a:off x="731520" y="2834640"/>
-            <a:ext cx="5303520" cy="3474720"/>
+            <a:ext cx="5303520" cy="3017520"/>
           </a:xfrm>
           <a:prstGeom prst="rect">
             <a:avLst/>
@@ -5078,7 +5078,7 @@
               <a:spcAft>
                 <a:spcPts val="100"/>
               </a:spcAft>
-              <a:defRPr sz="1300">
+              <a:defRPr sz="1800">
                 <a:solidFill>
                   <a:srgbClr val="333333"/>
                 </a:solidFill>
@@ -5094,7 +5094,7 @@
               <a:spcAft>
                 <a:spcPts val="100"/>
               </a:spcAft>
-              <a:defRPr sz="1300">
+              <a:defRPr sz="1800">
                 <a:solidFill>
                   <a:srgbClr val="333333"/>
                 </a:solidFill>
@@ -5110,7 +5110,7 @@
               <a:spcAft>
                 <a:spcPts val="100"/>
               </a:spcAft>
-              <a:defRPr sz="1300">
+              <a:defRPr sz="1800">
                 <a:solidFill>
                   <a:srgbClr val="333333"/>
                 </a:solidFill>
@@ -5126,7 +5126,7 @@
               <a:spcAft>
                 <a:spcPts val="100"/>
               </a:spcAft>
-              <a:defRPr sz="1300">
+              <a:defRPr sz="1800">
                 <a:solidFill>
                   <a:srgbClr val="333333"/>
                 </a:solidFill>
@@ -5142,7 +5142,7 @@
               <a:spcAft>
                 <a:spcPts val="100"/>
               </a:spcAft>
-              <a:defRPr sz="1300">
+              <a:defRPr sz="1800">
                 <a:solidFill>
                   <a:srgbClr val="333333"/>
                 </a:solidFill>
@@ -5158,20 +5158,20 @@
               <a:spcAft>
                 <a:spcPts val="100"/>
               </a:spcAft>
-              <a:defRPr sz="1300">
-                <a:solidFill>
-                  <a:srgbClr val="333333"/>
-                </a:solidFill>
-                <a:latin typeface="Courier New"/>
-              </a:defRPr>
-            </a:pPr>
-          </a:p>
-          <a:p>
-            <a:pPr>
-              <a:spcAft>
-                <a:spcPts val="100"/>
-              </a:spcAft>
-              <a:defRPr sz="1300">
+              <a:defRPr sz="1800">
+                <a:solidFill>
+                  <a:srgbClr val="333333"/>
+                </a:solidFill>
+                <a:latin typeface="Courier New"/>
+              </a:defRPr>
+            </a:pPr>
+          </a:p>
+          <a:p>
+            <a:pPr>
+              <a:spcAft>
+                <a:spcPts val="100"/>
+              </a:spcAft>
+              <a:defRPr sz="1800">
                 <a:solidFill>
                   <a:srgbClr val="333333"/>
                 </a:solidFill>
@@ -5187,7 +5187,7 @@
               <a:spcAft>
                 <a:spcPts val="100"/>
               </a:spcAft>
-              <a:defRPr sz="1300">
+              <a:defRPr sz="1800">
                 <a:solidFill>
                   <a:srgbClr val="333333"/>
                 </a:solidFill>
@@ -5203,7 +5203,7 @@
               <a:spcAft>
                 <a:spcPts val="100"/>
               </a:spcAft>
-              <a:defRPr sz="1300">
+              <a:defRPr sz="1800">
                 <a:solidFill>
                   <a:srgbClr val="333333"/>
                 </a:solidFill>
@@ -5219,7 +5219,7 @@
               <a:spcAft>
                 <a:spcPts val="100"/>
               </a:spcAft>
-              <a:defRPr sz="1300">
+              <a:defRPr sz="1800">
                 <a:solidFill>
                   <a:srgbClr val="333333"/>
                 </a:solidFill>
@@ -5235,7 +5235,7 @@
               <a:spcAft>
                 <a:spcPts val="100"/>
               </a:spcAft>
-              <a:defRPr sz="1300">
+              <a:defRPr sz="1800">
                 <a:solidFill>
                   <a:srgbClr val="333333"/>
                 </a:solidFill>
@@ -5251,7 +5251,7 @@
               <a:spcAft>
                 <a:spcPts val="100"/>
               </a:spcAft>
-              <a:defRPr sz="1300">
+              <a:defRPr sz="1800">
                 <a:solidFill>
                   <a:srgbClr val="333333"/>
                 </a:solidFill>
@@ -5267,20 +5267,20 @@
               <a:spcAft>
                 <a:spcPts val="100"/>
               </a:spcAft>
-              <a:defRPr sz="1300">
-                <a:solidFill>
-                  <a:srgbClr val="333333"/>
-                </a:solidFill>
-                <a:latin typeface="Courier New"/>
-              </a:defRPr>
-            </a:pPr>
-          </a:p>
-          <a:p>
-            <a:pPr>
-              <a:spcAft>
-                <a:spcPts val="100"/>
-              </a:spcAft>
-              <a:defRPr sz="1300">
+              <a:defRPr sz="1800">
+                <a:solidFill>
+                  <a:srgbClr val="333333"/>
+                </a:solidFill>
+                <a:latin typeface="Courier New"/>
+              </a:defRPr>
+            </a:pPr>
+          </a:p>
+          <a:p>
+            <a:pPr>
+              <a:spcAft>
+                <a:spcPts val="100"/>
+              </a:spcAft>
+              <a:defRPr sz="1800">
                 <a:solidFill>
                   <a:srgbClr val="333333"/>
                 </a:solidFill>
@@ -5296,7 +5296,7 @@
               <a:spcAft>
                 <a:spcPts val="100"/>
               </a:spcAft>
-              <a:defRPr sz="1300">
+              <a:defRPr sz="1800">
                 <a:solidFill>
                   <a:srgbClr val="333333"/>
                 </a:solidFill>
@@ -5318,7 +5318,7 @@
         <p:spPr>
           <a:xfrm>
             <a:off x="6583680" y="2743200"/>
-            <a:ext cx="5029200" cy="3657600"/>
+            <a:ext cx="5029200" cy="3200400"/>
           </a:xfrm>
           <a:prstGeom prst="rect">
             <a:avLst/>
@@ -5621,7 +5621,7 @@
               <a:spcAft>
                 <a:spcPts val="100"/>
               </a:spcAft>
-              <a:defRPr sz="1300">
+              <a:defRPr sz="1800">
                 <a:solidFill>
                   <a:srgbClr val="333333"/>
                 </a:solidFill>
@@ -5637,7 +5637,7 @@
               <a:spcAft>
                 <a:spcPts val="100"/>
               </a:spcAft>
-              <a:defRPr sz="1300">
+              <a:defRPr sz="1800">
                 <a:solidFill>
                   <a:srgbClr val="333333"/>
                 </a:solidFill>
@@ -5653,20 +5653,20 @@
               <a:spcAft>
                 <a:spcPts val="100"/>
               </a:spcAft>
-              <a:defRPr sz="1300">
-                <a:solidFill>
-                  <a:srgbClr val="333333"/>
-                </a:solidFill>
-                <a:latin typeface="Courier New"/>
-              </a:defRPr>
-            </a:pPr>
-          </a:p>
-          <a:p>
-            <a:pPr>
-              <a:spcAft>
-                <a:spcPts val="100"/>
-              </a:spcAft>
-              <a:defRPr sz="1300">
+              <a:defRPr sz="1800">
+                <a:solidFill>
+                  <a:srgbClr val="333333"/>
+                </a:solidFill>
+                <a:latin typeface="Courier New"/>
+              </a:defRPr>
+            </a:pPr>
+          </a:p>
+          <a:p>
+            <a:pPr>
+              <a:spcAft>
+                <a:spcPts val="100"/>
+              </a:spcAft>
+              <a:defRPr sz="1800">
                 <a:solidFill>
                   <a:srgbClr val="333333"/>
                 </a:solidFill>
@@ -5682,7 +5682,7 @@
               <a:spcAft>
                 <a:spcPts val="100"/>
               </a:spcAft>
-              <a:defRPr sz="1300">
+              <a:defRPr sz="1800">
                 <a:solidFill>
                   <a:srgbClr val="333333"/>
                 </a:solidFill>
@@ -5766,7 +5766,7 @@
               <a:spcAft>
                 <a:spcPts val="100"/>
               </a:spcAft>
-              <a:defRPr sz="1300">
+              <a:defRPr sz="1800">
                 <a:solidFill>
                   <a:srgbClr val="333333"/>
                 </a:solidFill>
@@ -5782,7 +5782,7 @@
               <a:spcAft>
                 <a:spcPts val="100"/>
               </a:spcAft>
-              <a:defRPr sz="1300">
+              <a:defRPr sz="1800">
                 <a:solidFill>
                   <a:srgbClr val="333333"/>
                 </a:solidFill>
@@ -5798,7 +5798,7 @@
               <a:spcAft>
                 <a:spcPts val="100"/>
               </a:spcAft>
-              <a:defRPr sz="1300">
+              <a:defRPr sz="1800">
                 <a:solidFill>
                   <a:srgbClr val="333333"/>
                 </a:solidFill>
@@ -5814,20 +5814,20 @@
               <a:spcAft>
                 <a:spcPts val="100"/>
               </a:spcAft>
-              <a:defRPr sz="1300">
-                <a:solidFill>
-                  <a:srgbClr val="333333"/>
-                </a:solidFill>
-                <a:latin typeface="Courier New"/>
-              </a:defRPr>
-            </a:pPr>
-          </a:p>
-          <a:p>
-            <a:pPr>
-              <a:spcAft>
-                <a:spcPts val="100"/>
-              </a:spcAft>
-              <a:defRPr sz="1300">
+              <a:defRPr sz="1800">
+                <a:solidFill>
+                  <a:srgbClr val="333333"/>
+                </a:solidFill>
+                <a:latin typeface="Courier New"/>
+              </a:defRPr>
+            </a:pPr>
+          </a:p>
+          <a:p>
+            <a:pPr>
+              <a:spcAft>
+                <a:spcPts val="100"/>
+              </a:spcAft>
+              <a:defRPr sz="1800">
                 <a:solidFill>
                   <a:srgbClr val="333333"/>
                 </a:solidFill>
@@ -5843,7 +5843,7 @@
               <a:spcAft>
                 <a:spcPts val="100"/>
               </a:spcAft>
-              <a:defRPr sz="1300">
+              <a:defRPr sz="1800">
                 <a:solidFill>
                   <a:srgbClr val="333333"/>
                 </a:solidFill>
@@ -6216,7 +6216,7 @@
               <a:spcAft>
                 <a:spcPts val="100"/>
               </a:spcAft>
-              <a:defRPr sz="1300">
+              <a:defRPr sz="1800">
                 <a:solidFill>
                   <a:srgbClr val="333333"/>
                 </a:solidFill>
@@ -6232,7 +6232,7 @@
               <a:spcAft>
                 <a:spcPts val="100"/>
               </a:spcAft>
-              <a:defRPr sz="1300">
+              <a:defRPr sz="1800">
                 <a:solidFill>
                   <a:srgbClr val="333333"/>
                 </a:solidFill>
@@ -6248,7 +6248,7 @@
               <a:spcAft>
                 <a:spcPts val="100"/>
               </a:spcAft>
-              <a:defRPr sz="1300">
+              <a:defRPr sz="1800">
                 <a:solidFill>
                   <a:srgbClr val="333333"/>
                 </a:solidFill>
@@ -6264,7 +6264,7 @@
               <a:spcAft>
                 <a:spcPts val="100"/>
               </a:spcAft>
-              <a:defRPr sz="1300">
+              <a:defRPr sz="1800">
                 <a:solidFill>
                   <a:srgbClr val="333333"/>
                 </a:solidFill>
@@ -6348,7 +6348,7 @@
               <a:spcAft>
                 <a:spcPts val="100"/>
               </a:spcAft>
-              <a:defRPr sz="1300">
+              <a:defRPr sz="1800">
                 <a:solidFill>
                   <a:srgbClr val="333333"/>
                 </a:solidFill>
@@ -6518,7 +6518,7 @@
         </p:nvSpPr>
         <p:spPr>
           <a:xfrm>
-            <a:off x="548640" y="1371600"/>
+            <a:off x="548640" y="1645920"/>
             <a:ext cx="10972800" cy="1645920"/>
           </a:xfrm>
           <a:prstGeom prst="roundRect">
@@ -6563,7 +6563,7 @@
         </p:nvSpPr>
         <p:spPr>
           <a:xfrm>
-            <a:off x="731520" y="1463040"/>
+            <a:off x="731520" y="1737360"/>
             <a:ext cx="10607040" cy="1463040"/>
           </a:xfrm>
           <a:prstGeom prst="rect">
@@ -6581,7 +6581,7 @@
               <a:spcAft>
                 <a:spcPts val="100"/>
               </a:spcAft>
-              <a:defRPr sz="1300">
+              <a:defRPr sz="1800">
                 <a:solidFill>
                   <a:srgbClr val="333333"/>
                 </a:solidFill>
@@ -6597,7 +6597,7 @@
               <a:spcAft>
                 <a:spcPts val="100"/>
               </a:spcAft>
-              <a:defRPr sz="1300">
+              <a:defRPr sz="1800">
                 <a:solidFill>
                   <a:srgbClr val="333333"/>
                 </a:solidFill>
@@ -6613,7 +6613,7 @@
               <a:spcAft>
                 <a:spcPts val="100"/>
               </a:spcAft>
-              <a:defRPr sz="1300">
+              <a:defRPr sz="1800">
                 <a:solidFill>
                   <a:srgbClr val="333333"/>
                 </a:solidFill>
@@ -6629,7 +6629,7 @@
               <a:spcAft>
                 <a:spcPts val="100"/>
               </a:spcAft>
-              <a:defRPr sz="1300">
+              <a:defRPr sz="1800">
                 <a:solidFill>
                   <a:srgbClr val="333333"/>
                 </a:solidFill>
@@ -6645,7 +6645,7 @@
               <a:spcAft>
                 <a:spcPts val="100"/>
               </a:spcAft>
-              <a:defRPr sz="1300">
+              <a:defRPr sz="1800">
                 <a:solidFill>
                   <a:srgbClr val="333333"/>
                 </a:solidFill>
@@ -6661,7 +6661,7 @@
               <a:spcAft>
                 <a:spcPts val="100"/>
               </a:spcAft>
-              <a:defRPr sz="1300">
+              <a:defRPr sz="1800">
                 <a:solidFill>
                   <a:srgbClr val="333333"/>
                 </a:solidFill>
@@ -6682,7 +6682,7 @@
         </p:nvSpPr>
         <p:spPr>
           <a:xfrm>
-            <a:off x="548640" y="3154680"/>
+            <a:off x="548640" y="3429000"/>
             <a:ext cx="10972800" cy="365760"/>
           </a:xfrm>
           <a:prstGeom prst="rect">
@@ -6782,7 +6782,7 @@
         </p:nvSpPr>
         <p:spPr>
           <a:xfrm>
-            <a:off x="548640" y="3154680"/>
+            <a:off x="548640" y="4251960"/>
             <a:ext cx="10972800" cy="960120"/>
           </a:xfrm>
           <a:prstGeom prst="roundRect">
@@ -6827,7 +6827,7 @@
         </p:nvSpPr>
         <p:spPr>
           <a:xfrm>
-            <a:off x="731520" y="3246120"/>
+            <a:off x="731520" y="4343400"/>
             <a:ext cx="10607040" cy="777240"/>
           </a:xfrm>
           <a:prstGeom prst="rect">
@@ -6845,7 +6845,7 @@
               <a:spcAft>
                 <a:spcPts val="100"/>
               </a:spcAft>
-              <a:defRPr sz="1300">
+              <a:defRPr sz="1800">
                 <a:solidFill>
                   <a:srgbClr val="333333"/>
                 </a:solidFill>
@@ -6861,7 +6861,7 @@
               <a:spcAft>
                 <a:spcPts val="100"/>
               </a:spcAft>
-              <a:defRPr sz="1300">
+              <a:defRPr sz="1800">
                 <a:solidFill>
                   <a:srgbClr val="333333"/>
                 </a:solidFill>
@@ -6877,7 +6877,7 @@
               <a:spcAft>
                 <a:spcPts val="100"/>
               </a:spcAft>
-              <a:defRPr sz="1300">
+              <a:defRPr sz="1800">
                 <a:solidFill>
                   <a:srgbClr val="333333"/>
                 </a:solidFill>
@@ -6898,7 +6898,7 @@
         </p:nvSpPr>
         <p:spPr>
           <a:xfrm>
-            <a:off x="548640" y="4251960"/>
+            <a:off x="548640" y="5349240"/>
             <a:ext cx="10972800" cy="365760"/>
           </a:xfrm>
           <a:prstGeom prst="rect">
@@ -6926,67 +6926,6 @@
             <a:r>
               <a:t>Key Rules:</a:t>
             </a:r>
-          </a:p>
-          <a:p>
-            <a:pPr>
-              <a:spcAft>
-                <a:spcPts val="400"/>
-              </a:spcAft>
-              <a:defRPr sz="1700" b="0">
-                <a:solidFill>
-                  <a:srgbClr val="000000"/>
-                </a:solidFill>
-                <a:latin typeface="Calibri"/>
-              </a:defRPr>
-            </a:pPr>
-            <a:r>
-              <a:t>Parameter order matters</a:t>
-            </a:r>
-          </a:p>
-          <a:p>
-            <a:pPr>
-              <a:spcAft>
-                <a:spcPts val="400"/>
-              </a:spcAft>
-              <a:defRPr sz="1700" b="0">
-                <a:solidFill>
-                  <a:srgbClr val="000000"/>
-                </a:solidFill>
-                <a:latin typeface="Calibri"/>
-              </a:defRPr>
-            </a:pPr>
-            <a:r>
-              <a:t>Argument count must match parameter count</a:t>
-            </a:r>
-          </a:p>
-          <a:p>
-            <a:pPr>
-              <a:spcAft>
-                <a:spcPts val="400"/>
-              </a:spcAft>
-              <a:defRPr sz="1700" b="0">
-                <a:solidFill>
-                  <a:srgbClr val="000000"/>
-                </a:solidFill>
-                <a:latin typeface="Calibri"/>
-              </a:defRPr>
-            </a:pPr>
-            <a:r>
-              <a:t>Python = dynamic (arguments can be numbers OR variables)</a:t>
-            </a:r>
-          </a:p>
-          <a:p>
-            <a:pPr>
-              <a:spcAft>
-                <a:spcPts val="400"/>
-              </a:spcAft>
-              <a:defRPr sz="400" b="0">
-                <a:solidFill>
-                  <a:srgbClr val="000000"/>
-                </a:solidFill>
-                <a:latin typeface="Calibri"/>
-              </a:defRPr>
-            </a:pPr>
           </a:p>
         </p:txBody>
       </p:sp>
@@ -7298,7 +7237,7 @@
               <a:spcAft>
                 <a:spcPts val="100"/>
               </a:spcAft>
-              <a:defRPr sz="1300">
+              <a:defRPr sz="1800">
                 <a:solidFill>
                   <a:srgbClr val="333333"/>
                 </a:solidFill>
@@ -7314,7 +7253,7 @@
               <a:spcAft>
                 <a:spcPts val="100"/>
               </a:spcAft>
-              <a:defRPr sz="1300">
+              <a:defRPr sz="1800">
                 <a:solidFill>
                   <a:srgbClr val="333333"/>
                 </a:solidFill>
@@ -7330,7 +7269,7 @@
               <a:spcAft>
                 <a:spcPts val="100"/>
               </a:spcAft>
-              <a:defRPr sz="1300">
+              <a:defRPr sz="1800">
                 <a:solidFill>
                   <a:srgbClr val="333333"/>
                 </a:solidFill>
@@ -7346,7 +7285,7 @@
               <a:spcAft>
                 <a:spcPts val="100"/>
               </a:spcAft>
-              <a:defRPr sz="1300">
+              <a:defRPr sz="1800">
                 <a:solidFill>
                   <a:srgbClr val="333333"/>
                 </a:solidFill>
@@ -7362,20 +7301,20 @@
               <a:spcAft>
                 <a:spcPts val="100"/>
               </a:spcAft>
-              <a:defRPr sz="1300">
-                <a:solidFill>
-                  <a:srgbClr val="333333"/>
-                </a:solidFill>
-                <a:latin typeface="Courier New"/>
-              </a:defRPr>
-            </a:pPr>
-          </a:p>
-          <a:p>
-            <a:pPr>
-              <a:spcAft>
-                <a:spcPts val="100"/>
-              </a:spcAft>
-              <a:defRPr sz="1300">
+              <a:defRPr sz="1800">
+                <a:solidFill>
+                  <a:srgbClr val="333333"/>
+                </a:solidFill>
+                <a:latin typeface="Courier New"/>
+              </a:defRPr>
+            </a:pPr>
+          </a:p>
+          <a:p>
+            <a:pPr>
+              <a:spcAft>
+                <a:spcPts val="100"/>
+              </a:spcAft>
+              <a:defRPr sz="1800">
                 <a:solidFill>
                   <a:srgbClr val="333333"/>
                 </a:solidFill>
@@ -7459,7 +7398,7 @@
               <a:spcAft>
                 <a:spcPts val="100"/>
               </a:spcAft>
-              <a:defRPr sz="1300">
+              <a:defRPr sz="1800">
                 <a:solidFill>
                   <a:srgbClr val="333333"/>
                 </a:solidFill>
@@ -7475,7 +7414,7 @@
               <a:spcAft>
                 <a:spcPts val="100"/>
               </a:spcAft>
-              <a:defRPr sz="1300">
+              <a:defRPr sz="1800">
                 <a:solidFill>
                   <a:srgbClr val="333333"/>
                 </a:solidFill>
@@ -7491,7 +7430,7 @@
               <a:spcAft>
                 <a:spcPts val="100"/>
               </a:spcAft>
-              <a:defRPr sz="1300">
+              <a:defRPr sz="1800">
                 <a:solidFill>
                   <a:srgbClr val="333333"/>
                 </a:solidFill>
@@ -7507,7 +7446,7 @@
               <a:spcAft>
                 <a:spcPts val="100"/>
               </a:spcAft>
-              <a:defRPr sz="1300">
+              <a:defRPr sz="1800">
                 <a:solidFill>
                   <a:srgbClr val="333333"/>
                 </a:solidFill>
@@ -7523,20 +7462,20 @@
               <a:spcAft>
                 <a:spcPts val="100"/>
               </a:spcAft>
-              <a:defRPr sz="1300">
-                <a:solidFill>
-                  <a:srgbClr val="333333"/>
-                </a:solidFill>
-                <a:latin typeface="Courier New"/>
-              </a:defRPr>
-            </a:pPr>
-          </a:p>
-          <a:p>
-            <a:pPr>
-              <a:spcAft>
-                <a:spcPts val="100"/>
-              </a:spcAft>
-              <a:defRPr sz="1300">
+              <a:defRPr sz="1800">
+                <a:solidFill>
+                  <a:srgbClr val="333333"/>
+                </a:solidFill>
+                <a:latin typeface="Courier New"/>
+              </a:defRPr>
+            </a:pPr>
+          </a:p>
+          <a:p>
+            <a:pPr>
+              <a:spcAft>
+                <a:spcPts val="100"/>
+              </a:spcAft>
+              <a:defRPr sz="1800">
                 <a:solidFill>
                   <a:srgbClr val="333333"/>
                 </a:solidFill>
@@ -7877,7 +7816,7 @@
               <a:spcAft>
                 <a:spcPts val="100"/>
               </a:spcAft>
-              <a:defRPr sz="1300">
+              <a:defRPr sz="1800">
                 <a:solidFill>
                   <a:srgbClr val="333333"/>
                 </a:solidFill>
@@ -7893,7 +7832,7 @@
               <a:spcAft>
                 <a:spcPts val="100"/>
               </a:spcAft>
-              <a:defRPr sz="1300">
+              <a:defRPr sz="1800">
                 <a:solidFill>
                   <a:srgbClr val="333333"/>
                 </a:solidFill>
@@ -7909,7 +7848,7 @@
               <a:spcAft>
                 <a:spcPts val="100"/>
               </a:spcAft>
-              <a:defRPr sz="1300">
+              <a:defRPr sz="1800">
                 <a:solidFill>
                   <a:srgbClr val="333333"/>
                 </a:solidFill>
@@ -7925,7 +7864,7 @@
               <a:spcAft>
                 <a:spcPts val="100"/>
               </a:spcAft>
-              <a:defRPr sz="1300">
+              <a:defRPr sz="1800">
                 <a:solidFill>
                   <a:srgbClr val="333333"/>
                 </a:solidFill>
@@ -7941,7 +7880,7 @@
               <a:spcAft>
                 <a:spcPts val="100"/>
               </a:spcAft>
-              <a:defRPr sz="1300">
+              <a:defRPr sz="1800">
                 <a:solidFill>
                   <a:srgbClr val="333333"/>
                 </a:solidFill>
@@ -7957,7 +7896,7 @@
               <a:spcAft>
                 <a:spcPts val="100"/>
               </a:spcAft>
-              <a:defRPr sz="1300">
+              <a:defRPr sz="1800">
                 <a:solidFill>
                   <a:srgbClr val="333333"/>
                 </a:solidFill>
@@ -8041,7 +7980,7 @@
               <a:spcAft>
                 <a:spcPts val="100"/>
               </a:spcAft>
-              <a:defRPr sz="1300">
+              <a:defRPr sz="1800">
                 <a:solidFill>
                   <a:srgbClr val="333333"/>
                 </a:solidFill>
@@ -8057,7 +7996,7 @@
               <a:spcAft>
                 <a:spcPts val="100"/>
               </a:spcAft>
-              <a:defRPr sz="1300">
+              <a:defRPr sz="1800">
                 <a:solidFill>
                   <a:srgbClr val="333333"/>
                 </a:solidFill>
@@ -8073,7 +8012,7 @@
               <a:spcAft>
                 <a:spcPts val="100"/>
               </a:spcAft>
-              <a:defRPr sz="1300">
+              <a:defRPr sz="1800">
                 <a:solidFill>
                   <a:srgbClr val="333333"/>
                 </a:solidFill>
@@ -8414,7 +8353,7 @@
               <a:spcAft>
                 <a:spcPts val="100"/>
               </a:spcAft>
-              <a:defRPr sz="1300">
+              <a:defRPr sz="1800">
                 <a:solidFill>
                   <a:srgbClr val="333333"/>
                 </a:solidFill>
@@ -8430,7 +8369,7 @@
               <a:spcAft>
                 <a:spcPts val="100"/>
               </a:spcAft>
-              <a:defRPr sz="1300">
+              <a:defRPr sz="1800">
                 <a:solidFill>
                   <a:srgbClr val="333333"/>
                 </a:solidFill>
@@ -8446,7 +8385,7 @@
               <a:spcAft>
                 <a:spcPts val="100"/>
               </a:spcAft>
-              <a:defRPr sz="1300">
+              <a:defRPr sz="1800">
                 <a:solidFill>
                   <a:srgbClr val="333333"/>
                 </a:solidFill>
@@ -8462,20 +8401,20 @@
               <a:spcAft>
                 <a:spcPts val="100"/>
               </a:spcAft>
-              <a:defRPr sz="1300">
-                <a:solidFill>
-                  <a:srgbClr val="333333"/>
-                </a:solidFill>
-                <a:latin typeface="Courier New"/>
-              </a:defRPr>
-            </a:pPr>
-          </a:p>
-          <a:p>
-            <a:pPr>
-              <a:spcAft>
-                <a:spcPts val="100"/>
-              </a:spcAft>
-              <a:defRPr sz="1300">
+              <a:defRPr sz="1800">
+                <a:solidFill>
+                  <a:srgbClr val="333333"/>
+                </a:solidFill>
+                <a:latin typeface="Courier New"/>
+              </a:defRPr>
+            </a:pPr>
+          </a:p>
+          <a:p>
+            <a:pPr>
+              <a:spcAft>
+                <a:spcPts val="100"/>
+              </a:spcAft>
+              <a:defRPr sz="1800">
                 <a:solidFill>
                   <a:srgbClr val="333333"/>
                 </a:solidFill>
@@ -8491,7 +8430,7 @@
               <a:spcAft>
                 <a:spcPts val="100"/>
               </a:spcAft>
-              <a:defRPr sz="1300">
+              <a:defRPr sz="1800">
                 <a:solidFill>
                   <a:srgbClr val="333333"/>
                 </a:solidFill>
@@ -8507,20 +8446,20 @@
               <a:spcAft>
                 <a:spcPts val="100"/>
               </a:spcAft>
-              <a:defRPr sz="1300">
-                <a:solidFill>
-                  <a:srgbClr val="333333"/>
-                </a:solidFill>
-                <a:latin typeface="Courier New"/>
-              </a:defRPr>
-            </a:pPr>
-          </a:p>
-          <a:p>
-            <a:pPr>
-              <a:spcAft>
-                <a:spcPts val="100"/>
-              </a:spcAft>
-              <a:defRPr sz="1300">
+              <a:defRPr sz="1800">
+                <a:solidFill>
+                  <a:srgbClr val="333333"/>
+                </a:solidFill>
+                <a:latin typeface="Courier New"/>
+              </a:defRPr>
+            </a:pPr>
+          </a:p>
+          <a:p>
+            <a:pPr>
+              <a:spcAft>
+                <a:spcPts val="100"/>
+              </a:spcAft>
+              <a:defRPr sz="1800">
                 <a:solidFill>
                   <a:srgbClr val="333333"/>
                 </a:solidFill>
@@ -8604,7 +8543,7 @@
               <a:spcAft>
                 <a:spcPts val="100"/>
               </a:spcAft>
-              <a:defRPr sz="1300">
+              <a:defRPr sz="1800">
                 <a:solidFill>
                   <a:srgbClr val="333333"/>
                 </a:solidFill>
@@ -8620,7 +8559,7 @@
               <a:spcAft>
                 <a:spcPts val="100"/>
               </a:spcAft>
-              <a:defRPr sz="1300">
+              <a:defRPr sz="1800">
                 <a:solidFill>
                   <a:srgbClr val="333333"/>
                 </a:solidFill>
@@ -8636,7 +8575,7 @@
               <a:spcAft>
                 <a:spcPts val="100"/>
               </a:spcAft>
-              <a:defRPr sz="1300">
+              <a:defRPr sz="1800">
                 <a:solidFill>
                   <a:srgbClr val="333333"/>
                 </a:solidFill>
@@ -8652,7 +8591,7 @@
               <a:spcAft>
                 <a:spcPts val="100"/>
               </a:spcAft>
-              <a:defRPr sz="1300">
+              <a:defRPr sz="1800">
                 <a:solidFill>
                   <a:srgbClr val="333333"/>
                 </a:solidFill>
@@ -8668,7 +8607,7 @@
               <a:spcAft>
                 <a:spcPts val="100"/>
               </a:spcAft>
-              <a:defRPr sz="1300">
+              <a:defRPr sz="1800">
                 <a:solidFill>
                   <a:srgbClr val="333333"/>
                 </a:solidFill>
@@ -8684,20 +8623,20 @@
               <a:spcAft>
                 <a:spcPts val="100"/>
               </a:spcAft>
-              <a:defRPr sz="1300">
-                <a:solidFill>
-                  <a:srgbClr val="333333"/>
-                </a:solidFill>
-                <a:latin typeface="Courier New"/>
-              </a:defRPr>
-            </a:pPr>
-          </a:p>
-          <a:p>
-            <a:pPr>
-              <a:spcAft>
-                <a:spcPts val="100"/>
-              </a:spcAft>
-              <a:defRPr sz="1300">
+              <a:defRPr sz="1800">
+                <a:solidFill>
+                  <a:srgbClr val="333333"/>
+                </a:solidFill>
+                <a:latin typeface="Courier New"/>
+              </a:defRPr>
+            </a:pPr>
+          </a:p>
+          <a:p>
+            <a:pPr>
+              <a:spcAft>
+                <a:spcPts val="100"/>
+              </a:spcAft>
+              <a:defRPr sz="1800">
                 <a:solidFill>
                   <a:srgbClr val="333333"/>
                 </a:solidFill>
@@ -8713,7 +8652,7 @@
               <a:spcAft>
                 <a:spcPts val="100"/>
               </a:spcAft>
-              <a:defRPr sz="1300">
+              <a:defRPr sz="1800">
                 <a:solidFill>
                   <a:srgbClr val="333333"/>
                 </a:solidFill>
@@ -9054,7 +8993,7 @@
               <a:spcAft>
                 <a:spcPts val="100"/>
               </a:spcAft>
-              <a:defRPr sz="1300">
+              <a:defRPr sz="1800">
                 <a:solidFill>
                   <a:srgbClr val="333333"/>
                 </a:solidFill>
@@ -9070,7 +9009,7 @@
               <a:spcAft>
                 <a:spcPts val="100"/>
               </a:spcAft>
-              <a:defRPr sz="1300">
+              <a:defRPr sz="1800">
                 <a:solidFill>
                   <a:srgbClr val="333333"/>
                 </a:solidFill>
@@ -9086,7 +9025,7 @@
               <a:spcAft>
                 <a:spcPts val="100"/>
               </a:spcAft>
-              <a:defRPr sz="1300">
+              <a:defRPr sz="1800">
                 <a:solidFill>
                   <a:srgbClr val="333333"/>
                 </a:solidFill>
@@ -9102,20 +9041,20 @@
               <a:spcAft>
                 <a:spcPts val="100"/>
               </a:spcAft>
-              <a:defRPr sz="1300">
-                <a:solidFill>
-                  <a:srgbClr val="333333"/>
-                </a:solidFill>
-                <a:latin typeface="Courier New"/>
-              </a:defRPr>
-            </a:pPr>
-          </a:p>
-          <a:p>
-            <a:pPr>
-              <a:spcAft>
-                <a:spcPts val="100"/>
-              </a:spcAft>
-              <a:defRPr sz="1300">
+              <a:defRPr sz="1800">
+                <a:solidFill>
+                  <a:srgbClr val="333333"/>
+                </a:solidFill>
+                <a:latin typeface="Courier New"/>
+              </a:defRPr>
+            </a:pPr>
+          </a:p>
+          <a:p>
+            <a:pPr>
+              <a:spcAft>
+                <a:spcPts val="100"/>
+              </a:spcAft>
+              <a:defRPr sz="1800">
                 <a:solidFill>
                   <a:srgbClr val="333333"/>
                 </a:solidFill>
@@ -9199,7 +9138,7 @@
               <a:spcAft>
                 <a:spcPts val="100"/>
               </a:spcAft>
-              <a:defRPr sz="1300">
+              <a:defRPr sz="1800">
                 <a:solidFill>
                   <a:srgbClr val="333333"/>
                 </a:solidFill>
@@ -9215,7 +9154,7 @@
               <a:spcAft>
                 <a:spcPts val="100"/>
               </a:spcAft>
-              <a:defRPr sz="1300">
+              <a:defRPr sz="1800">
                 <a:solidFill>
                   <a:srgbClr val="333333"/>
                 </a:solidFill>
@@ -9231,7 +9170,7 @@
               <a:spcAft>
                 <a:spcPts val="100"/>
               </a:spcAft>
-              <a:defRPr sz="1300">
+              <a:defRPr sz="1800">
                 <a:solidFill>
                   <a:srgbClr val="333333"/>
                 </a:solidFill>
@@ -9247,20 +9186,20 @@
               <a:spcAft>
                 <a:spcPts val="100"/>
               </a:spcAft>
-              <a:defRPr sz="1300">
-                <a:solidFill>
-                  <a:srgbClr val="333333"/>
-                </a:solidFill>
-                <a:latin typeface="Courier New"/>
-              </a:defRPr>
-            </a:pPr>
-          </a:p>
-          <a:p>
-            <a:pPr>
-              <a:spcAft>
-                <a:spcPts val="100"/>
-              </a:spcAft>
-              <a:defRPr sz="1300">
+              <a:defRPr sz="1800">
+                <a:solidFill>
+                  <a:srgbClr val="333333"/>
+                </a:solidFill>
+                <a:latin typeface="Courier New"/>
+              </a:defRPr>
+            </a:pPr>
+          </a:p>
+          <a:p>
+            <a:pPr>
+              <a:spcAft>
+                <a:spcPts val="100"/>
+              </a:spcAft>
+              <a:defRPr sz="1800">
                 <a:solidFill>
                   <a:srgbClr val="333333"/>
                 </a:solidFill>
@@ -9276,7 +9215,7 @@
               <a:spcAft>
                 <a:spcPts val="100"/>
               </a:spcAft>
-              <a:defRPr sz="1300">
+              <a:defRPr sz="1800">
                 <a:solidFill>
                   <a:srgbClr val="333333"/>
                 </a:solidFill>
@@ -9649,7 +9588,7 @@
               <a:spcAft>
                 <a:spcPts val="100"/>
               </a:spcAft>
-              <a:defRPr sz="1300">
+              <a:defRPr sz="1800">
                 <a:solidFill>
                   <a:srgbClr val="333333"/>
                 </a:solidFill>
@@ -9665,7 +9604,7 @@
               <a:spcAft>
                 <a:spcPts val="100"/>
               </a:spcAft>
-              <a:defRPr sz="1300">
+              <a:defRPr sz="1800">
                 <a:solidFill>
                   <a:srgbClr val="333333"/>
                 </a:solidFill>
@@ -9681,7 +9620,7 @@
               <a:spcAft>
                 <a:spcPts val="100"/>
               </a:spcAft>
-              <a:defRPr sz="1300">
+              <a:defRPr sz="1800">
                 <a:solidFill>
                   <a:srgbClr val="333333"/>
                 </a:solidFill>
@@ -9697,7 +9636,7 @@
               <a:spcAft>
                 <a:spcPts val="100"/>
               </a:spcAft>
-              <a:defRPr sz="1300">
+              <a:defRPr sz="1800">
                 <a:solidFill>
                   <a:srgbClr val="333333"/>
                 </a:solidFill>
@@ -9713,7 +9652,7 @@
               <a:spcAft>
                 <a:spcPts val="100"/>
               </a:spcAft>
-              <a:defRPr sz="1300">
+              <a:defRPr sz="1800">
                 <a:solidFill>
                   <a:srgbClr val="333333"/>
                 </a:solidFill>
@@ -9797,7 +9736,7 @@
               <a:spcAft>
                 <a:spcPts val="100"/>
               </a:spcAft>
-              <a:defRPr sz="1300">
+              <a:defRPr sz="1800">
                 <a:solidFill>
                   <a:srgbClr val="333333"/>
                 </a:solidFill>
@@ -9813,7 +9752,7 @@
               <a:spcAft>
                 <a:spcPts val="100"/>
               </a:spcAft>
-              <a:defRPr sz="1300">
+              <a:defRPr sz="1800">
                 <a:solidFill>
                   <a:srgbClr val="333333"/>
                 </a:solidFill>
@@ -9829,7 +9768,7 @@
               <a:spcAft>
                 <a:spcPts val="100"/>
               </a:spcAft>
-              <a:defRPr sz="1300">
+              <a:defRPr sz="1800">
                 <a:solidFill>
                   <a:srgbClr val="333333"/>
                 </a:solidFill>
@@ -9845,7 +9784,7 @@
               <a:spcAft>
                 <a:spcPts val="100"/>
               </a:spcAft>
-              <a:defRPr sz="1300">
+              <a:defRPr sz="1800">
                 <a:solidFill>
                   <a:srgbClr val="333333"/>
                 </a:solidFill>
@@ -9861,7 +9800,7 @@
               <a:spcAft>
                 <a:spcPts val="100"/>
               </a:spcAft>
-              <a:defRPr sz="1300">
+              <a:defRPr sz="1800">
                 <a:solidFill>
                   <a:srgbClr val="333333"/>
                 </a:solidFill>

</xml_diff>